<commit_message>
Reestruturar o banner no formato dos trabalhos aprovados
Introdução, Revisão de Literatura, três figuras com legenda, Conclusão e
Referências. A caixa de Material e Métodos do modelo vira Revisão de Literatura
e a de Resultados sai, abrindo a faixa central para as fotos.

Três molduras de 26,5 x 21 cm com legenda entram como formas novas, na fonte e
na cor do modelo, para serem preenchidas com as imagens do caso.

Co-Authored-By: Claude Opus 5 <noreply@anthropic.com>
Claude-Session: https://claude.ai/code/session_01KV9dw4gzFi44p1bVc4t4nV
</commit_message>
<xml_diff>
--- a/banner-pne/Banner_PNE_TEA.pptx
+++ b/banner-pne/Banner_PNE_TEA.pptx
@@ -15000,7 +15000,7 @@
                 <a:cs typeface="Arial"/>
                 <a:sym typeface="Arial"/>
               </a:rPr>
-              <a:t>Autores*: Thamyres Tosarelli, Beatriz Gouvea</a:t>
+              <a:t>Autores*: Tosarelli, T.; Gouvea, B.</a:t>
             </a:r>
             <a:endParaRPr b="0" i="0" sz="1400" u="none" cap="none" strike="noStrike">
               <a:solidFill>
@@ -15040,7 +15040,7 @@
                 <a:cs typeface="Arial"/>
                 <a:sym typeface="Arial"/>
               </a:rPr>
-              <a:t>Orientadores**: Rosemary Baptista Martins Teixeira, Ricardo Matsura Kodama</a:t>
+              <a:t>Orientadores**: Teixeira, R. B. M.; Kodama, R. M.</a:t>
             </a:r>
             <a:endParaRPr b="0" i="0" sz="4000" u="none" cap="none" strike="noStrike">
               <a:solidFill>
@@ -15062,7 +15062,7 @@
         </p:nvSpPr>
         <p:spPr>
           <a:xfrm>
-            <a:off x="434209" y="37980000"/>
+            <a:off x="434209" y="37440000"/>
             <a:ext cx="30996000" cy="3169500"/>
           </a:xfrm>
           <a:prstGeom prst="rect">
@@ -15815,7 +15815,7 @@
                 <a:cs typeface="Arial"/>
                 <a:sym typeface="Arial"/>
               </a:rPr>
-              <a:t>Introdução/ Revisão de Literatura</a:t>
+              <a:t>Introdução</a:t>
             </a:r>
             <a:endParaRPr b="0" i="0" sz="1400" u="none" cap="none" strike="noStrike">
               <a:solidFill>
@@ -15855,7 +15855,7 @@
                 <a:cs typeface="Arial"/>
                 <a:sym typeface="Arial"/>
               </a:rPr>
-              <a:t>O Transtorno do Espectro Autista (TEA) nível 3 exige maior suporte, com comunicação verbal limitada, comportamentos repetitivos e alterações sensoriais. Com frequência vem acompanhado do Transtorno de Déficit de Atenção e Hiperatividade (TDAH) e do Transtorno de Ansiedade Generalizada (TAG), o que reduz a colaboração no consultório. Esses pacientes têm maior risco de cárie e de doença periodontal, pois a higiene bucal depende do cuidador, a dieta costuma ser seletiva e cariogênica e os psicofármacos reduzem o fluxo salivar.</a:t>
+              <a:t>O Transtorno do Espectro Autista (TEA) é um distúrbio do neurodesenvolvimento que altera a comunicação, a interação social e o comportamento. No nível 3, o mais grave, o paciente necessita de apoio muito substancial: a comunicação verbal é limitada, há comportamentos repetitivos e alterações no processamento sensorial, o que torna o atendimento odontológico um desafio para toda a equipe.</a:t>
             </a:r>
             <a:endParaRPr b="0" i="0" sz="1400" u="none" cap="none" strike="noStrike">
               <a:solidFill>
@@ -15877,7 +15877,7 @@
         </p:nvSpPr>
         <p:spPr>
           <a:xfrm>
-            <a:off x="754332" y="15552000"/>
+            <a:off x="754332" y="14400000"/>
             <a:ext cx="31016700" cy="2184600"/>
           </a:xfrm>
           <a:prstGeom prst="rect">
@@ -15921,7 +15921,7 @@
                 <a:cs typeface="Arial"/>
                 <a:sym typeface="Arial"/>
               </a:rPr>
-              <a:t>Material e Métodos</a:t>
+              <a:t>Revisão de Literatura</a:t>
             </a:r>
             <a:endParaRPr b="0" i="0" sz="1400" u="none" cap="none" strike="noStrike">
               <a:solidFill>
@@ -15961,7 +15961,47 @@
                 <a:cs typeface="Arial"/>
                 <a:sym typeface="Arial"/>
               </a:rPr>
-              <a:t>O atendimento começa por anamnese detalhada com o responsável, que informa a rotina da criança, a forma de comunicação e os estímulos que causam desconforto. As consultas devem ser curtas, no mesmo horário, na mesma sala e com a mesma equipe, sendo a primeira apenas de adaptação, sem procedimento clínico. O condicionamento é gradual, por dessensibilização, associada ao dizer-mostrar-fazer, à pedagogia visual com pranchas e agendas de figuras, a vídeos que mostram o procedimento antes da consulta e ao reforço positivo a cada etapa cumprida. O ambiente é adaptado com redução de luz, ruído e odores, mantendo-se o cuidador presente.</a:t>
+              <a:t>A associação do TEA ao Transtorno de Déficit de Atenção e Hiperatividade (TDAH) e ao Transtorno de Ansiedade Generalizada (TAG) é frequente e reduz ainda mais a colaboração na cadeira odontológica. Esses pacientes apresentam maior risco de cárie e de doença periodontal, pois a higiene bucal depende do cuidador, a dieta costuma ser seletiva e cariogênica e os psicofármacos reduzem o fluxo salivar.</a:t>
+            </a:r>
+            <a:endParaRPr b="0" i="0" sz="1400" u="none" cap="none" strike="noStrike">
+              <a:solidFill>
+                <a:srgbClr val="000000"/>
+              </a:solidFill>
+              <a:latin typeface="Arial"/>
+              <a:ea typeface="Arial"/>
+              <a:cs typeface="Arial"/>
+              <a:sym typeface="Arial"/>
+            </a:endParaRPr>
+          </a:p>
+          <a:p>
+            <a:pPr indent="0" lvl="0" marL="0" marR="0" rtl="0" algn="just">
+              <a:lnSpc>
+                <a:spcPct val="100000"/>
+              </a:lnSpc>
+              <a:spcBef>
+                <a:spcPts val="0"/>
+              </a:spcBef>
+              <a:spcAft>
+                <a:spcPts val="0"/>
+              </a:spcAft>
+              <a:buClr>
+                <a:srgbClr val="000000"/>
+              </a:buClr>
+              <a:buSzPts val="4800"/>
+              <a:buFont typeface="Arial"/>
+              <a:buNone/>
+            </a:pPr>
+            <a:r>
+              <a:rPr b="0" i="0" lang="pt-BR" sz="4800" u="none" cap="none" strike="noStrike">
+                <a:solidFill>
+                  <a:schemeClr val="dk1"/>
+                </a:solidFill>
+                <a:latin typeface="Arial"/>
+                <a:ea typeface="Arial"/>
+                <a:cs typeface="Arial"/>
+                <a:sym typeface="Arial"/>
+              </a:rPr>
+              <a:t>A colaboração é construída, e não obtida de imediato. A anamnese deve ser detalhada com o responsável, identificando a rotina, a comunicação e os estímulos que causam desconforto. As consultas devem ser curtas, no mesmo horário, sala e equipe, sendo a primeira apenas de adaptação. A dessensibilização, o dizer-mostrar-fazer, a pedagogia visual com pranchas e agendas de figuras, a modelagem por vídeo e o reforço positivo aumentam a cooperação e reduzem o número de consultas necessárias. A adaptação sensorial do ambiente, com redução de luz, ruído e odores, diminui o estresse fisiológico e comportamental. Contenção protetora, sedação e anestesia geral ficam reservadas à falha do manejo básico.</a:t>
             </a:r>
             <a:endParaRPr b="0" i="0" sz="1400" u="none" cap="none" strike="noStrike">
               <a:solidFill>
@@ -16028,152 +16068,6 @@
                 <a:sym typeface="Arial"/>
               </a:rPr>
               <a:t>MANEJO ODONTOLÓGICO DO PACIENTE COM TEA NÍVEL 3, TDAH E TAG</a:t>
-            </a:r>
-            <a:endParaRPr b="0" i="0" sz="1400" u="none" cap="none" strike="noStrike">
-              <a:solidFill>
-                <a:srgbClr val="000000"/>
-              </a:solidFill>
-              <a:latin typeface="Arial"/>
-              <a:ea typeface="Arial"/>
-              <a:cs typeface="Arial"/>
-              <a:sym typeface="Arial"/>
-            </a:endParaRPr>
-          </a:p>
-        </p:txBody>
-      </p:sp>
-      <p:sp>
-        <p:nvSpPr>
-          <p:cNvPr id="96" name="Google Shape;96;h3c4b9edaebb761c2_0_0"/>
-          <p:cNvSpPr txBox="1"/>
-          <p:nvPr/>
-        </p:nvSpPr>
-        <p:spPr>
-          <a:xfrm>
-            <a:off x="754332" y="24366539"/>
-            <a:ext cx="31535700" cy="2923200"/>
-          </a:xfrm>
-          <a:prstGeom prst="rect">
-            <a:avLst/>
-          </a:prstGeom>
-          <a:noFill/>
-          <a:ln>
-            <a:noFill/>
-          </a:ln>
-        </p:spPr>
-        <p:txBody>
-          <a:bodyPr anchorCtr="0" anchor="t" bIns="75600" lIns="151200" spcFirstLastPara="1" rIns="151200" wrap="square" tIns="75600">
-            <a:spAutoFit/>
-          </a:bodyPr>
-          <a:lstStyle/>
-          <a:p>
-            <a:pPr indent="0" lvl="0" marL="0" marR="0" rtl="0" algn="just">
-              <a:lnSpc>
-                <a:spcPct val="100000"/>
-              </a:lnSpc>
-              <a:spcBef>
-                <a:spcPts val="0"/>
-              </a:spcBef>
-              <a:spcAft>
-                <a:spcPts val="0"/>
-              </a:spcAft>
-              <a:buClr>
-                <a:srgbClr val="000000"/>
-              </a:buClr>
-              <a:buSzPts val="6600"/>
-              <a:buFont typeface="Arial"/>
-              <a:buNone/>
-            </a:pPr>
-            <a:r>
-              <a:rPr b="1" i="0" lang="pt-BR" sz="6600" u="none" cap="none" strike="noStrike">
-                <a:solidFill>
-                  <a:schemeClr val="dk1"/>
-                </a:solidFill>
-                <a:latin typeface="Arial"/>
-                <a:ea typeface="Arial"/>
-                <a:cs typeface="Arial"/>
-                <a:sym typeface="Arial"/>
-              </a:rPr>
-              <a:t>Resultados</a:t>
-            </a:r>
-            <a:endParaRPr b="0" i="0" sz="1400" u="none" cap="none" strike="noStrike">
-              <a:solidFill>
-                <a:srgbClr val="000000"/>
-              </a:solidFill>
-              <a:latin typeface="Arial"/>
-              <a:ea typeface="Arial"/>
-              <a:cs typeface="Arial"/>
-              <a:sym typeface="Arial"/>
-            </a:endParaRPr>
-          </a:p>
-          <a:p>
-            <a:pPr indent="0" lvl="0" marL="0" marR="0" rtl="0" algn="just">
-              <a:lnSpc>
-                <a:spcPct val="100000"/>
-              </a:lnSpc>
-              <a:spcBef>
-                <a:spcPts val="0"/>
-              </a:spcBef>
-              <a:spcAft>
-                <a:spcPts val="0"/>
-              </a:spcAft>
-              <a:buClr>
-                <a:srgbClr val="000000"/>
-              </a:buClr>
-              <a:buSzPts val="4800"/>
-              <a:buFont typeface="Arial"/>
-              <a:buNone/>
-            </a:pPr>
-            <a:r>
-              <a:rPr b="0" i="0" lang="pt-BR" sz="4800" u="none" cap="none" strike="noStrike">
-                <a:solidFill>
-                  <a:schemeClr val="dk1"/>
-                </a:solidFill>
-                <a:latin typeface="Arial"/>
-                <a:ea typeface="Arial"/>
-                <a:cs typeface="Arial"/>
-                <a:sym typeface="Arial"/>
-              </a:rPr>
-              <a:t>A pedagogia visual aumenta a cooperação e melhora a qualidade da escovação, e a modelagem por vídeo reduz o número de consultas necessárias para o atendimento não invasivo. A adaptação sensorial do ambiente reduz o estresse fisiológico e comportamental em todas as fases da consulta.</a:t>
-            </a:r>
-            <a:endParaRPr b="0" i="0" sz="1400" u="none" cap="none" strike="noStrike">
-              <a:solidFill>
-                <a:srgbClr val="000000"/>
-              </a:solidFill>
-              <a:latin typeface="Arial"/>
-              <a:ea typeface="Arial"/>
-              <a:cs typeface="Arial"/>
-              <a:sym typeface="Arial"/>
-            </a:endParaRPr>
-          </a:p>
-          <a:p>
-            <a:pPr indent="0" lvl="0" marL="0" marR="0" rtl="0" algn="just">
-              <a:lnSpc>
-                <a:spcPct val="100000"/>
-              </a:lnSpc>
-              <a:spcBef>
-                <a:spcPts val="0"/>
-              </a:spcBef>
-              <a:spcAft>
-                <a:spcPts val="0"/>
-              </a:spcAft>
-              <a:buClr>
-                <a:srgbClr val="000000"/>
-              </a:buClr>
-              <a:buSzPts val="4800"/>
-              <a:buFont typeface="Arial"/>
-              <a:buNone/>
-            </a:pPr>
-            <a:r>
-              <a:rPr b="0" i="0" lang="pt-BR" sz="4800" u="none" cap="none" strike="noStrike">
-                <a:solidFill>
-                  <a:schemeClr val="dk1"/>
-                </a:solidFill>
-                <a:latin typeface="Arial"/>
-                <a:ea typeface="Arial"/>
-                <a:cs typeface="Arial"/>
-                <a:sym typeface="Arial"/>
-              </a:rPr>
-              <a:t>A contenção protetora, a sedação e a anestesia geral permanecem indicadas apenas quando o manejo básico não é suficiente, mediante consentimento informado. Os estudos disponíveis, porém, têm amostras pequenas e grande heterogeneidade metodológica, o que impede a definição de um protocolo universal.</a:t>
             </a:r>
             <a:endParaRPr b="0" i="0" sz="1400" u="none" cap="none" strike="noStrike">
               <a:solidFill>
@@ -16222,7 +16116,7 @@
         </p:nvSpPr>
         <p:spPr>
           <a:xfrm>
-            <a:off x="715610" y="34661160"/>
+            <a:off x="715610" y="33480000"/>
             <a:ext cx="31535700" cy="2923200"/>
           </a:xfrm>
           <a:prstGeom prst="rect">
@@ -16306,7 +16200,7 @@
                 <a:cs typeface="Arial"/>
                 <a:sym typeface="Arial"/>
               </a:rPr>
-              <a:t>Não existe um protocolo único para esse perfil de paciente. O sucesso do atendimento depende da individualização, da previsibilidade, da capacitação da equipe e do vínculo com a família, e a ênfase na prevenção evita a necessidade de procedimentos mais invasivos.</a:t>
+              <a:t>Não existe protocolo único para o paciente com TEA. O sucesso do atendimento depende da individualização, da previsibilidade, da capacitação da equipe e do vínculo com a família. A ênfase na prevenção reduz a necessidade de contenção, sedação e anestesia geral.</a:t>
             </a:r>
             <a:endParaRPr b="0" i="0" sz="1400" u="none" cap="none" strike="noStrike">
               <a:solidFill>
@@ -16348,6 +16242,258 @@
           </a:ln>
         </p:spPr>
       </p:pic>
+      <p:sp>
+        <p:nvSpPr>
+          <p:cNvPr id="100" name="Moldura foto 1"/>
+          <p:cNvSpPr txBox="1"/>
+          <p:nvPr/>
+        </p:nvSpPr>
+        <p:spPr>
+          <a:xfrm>
+            <a:off x="720000" y="24480000"/>
+            <a:ext cx="9540000" cy="7560000"/>
+          </a:xfrm>
+          <a:prstGeom prst="rect">
+            <a:avLst/>
+          </a:prstGeom>
+          <a:solidFill>
+            <a:srgbClr val="FFFFFF">
+              <a:alpha val="55000"/>
+            </a:srgbClr>
+          </a:solidFill>
+          <a:ln w="28575">
+            <a:solidFill>
+              <a:srgbClr val="000066"/>
+            </a:solidFill>
+            <a:prstDash val="dash"/>
+          </a:ln>
+        </p:spPr>
+        <p:txBody>
+          <a:bodyPr anchor="ctr" wrap="square" lIns="91425" rIns="91425" tIns="45700" bIns="45700"/>
+          <a:lstStyle/>
+          <a:p>
+            <a:pPr algn="ctr">
+              <a:buNone/>
+            </a:pPr>
+            <a:r>
+              <a:rPr lang="pt-BR" sz="3600" b="0" i="0">
+                <a:solidFill>
+                  <a:srgbClr val="000066"/>
+                </a:solidFill>
+                <a:latin typeface="Arial"/>
+                <a:ea typeface="Arial"/>
+                <a:cs typeface="Arial"/>
+              </a:rPr>
+              <a:t>INSIRA A FOTO 1</a:t>
+            </a:r>
+          </a:p>
+        </p:txBody>
+      </p:sp>
+      <p:sp>
+        <p:nvSpPr>
+          <p:cNvPr id="101" name="Moldura foto 2"/>
+          <p:cNvSpPr txBox="1"/>
+          <p:nvPr/>
+        </p:nvSpPr>
+        <p:spPr>
+          <a:xfrm>
+            <a:off x="11430000" y="24480000"/>
+            <a:ext cx="9540000" cy="7560000"/>
+          </a:xfrm>
+          <a:prstGeom prst="rect">
+            <a:avLst/>
+          </a:prstGeom>
+          <a:solidFill>
+            <a:srgbClr val="FFFFFF">
+              <a:alpha val="55000"/>
+            </a:srgbClr>
+          </a:solidFill>
+          <a:ln w="28575">
+            <a:solidFill>
+              <a:srgbClr val="000066"/>
+            </a:solidFill>
+            <a:prstDash val="dash"/>
+          </a:ln>
+        </p:spPr>
+        <p:txBody>
+          <a:bodyPr anchor="ctr" wrap="square" lIns="91425" rIns="91425" tIns="45700" bIns="45700"/>
+          <a:lstStyle/>
+          <a:p>
+            <a:pPr algn="ctr">
+              <a:buNone/>
+            </a:pPr>
+            <a:r>
+              <a:rPr lang="pt-BR" sz="3600" b="0" i="0">
+                <a:solidFill>
+                  <a:srgbClr val="000066"/>
+                </a:solidFill>
+                <a:latin typeface="Arial"/>
+                <a:ea typeface="Arial"/>
+                <a:cs typeface="Arial"/>
+              </a:rPr>
+              <a:t>INSIRA A FOTO 2</a:t>
+            </a:r>
+          </a:p>
+        </p:txBody>
+      </p:sp>
+      <p:sp>
+        <p:nvSpPr>
+          <p:cNvPr id="102" name="Moldura foto 3"/>
+          <p:cNvSpPr txBox="1"/>
+          <p:nvPr/>
+        </p:nvSpPr>
+        <p:spPr>
+          <a:xfrm>
+            <a:off x="22140000" y="24480000"/>
+            <a:ext cx="9540000" cy="7560000"/>
+          </a:xfrm>
+          <a:prstGeom prst="rect">
+            <a:avLst/>
+          </a:prstGeom>
+          <a:solidFill>
+            <a:srgbClr val="FFFFFF">
+              <a:alpha val="55000"/>
+            </a:srgbClr>
+          </a:solidFill>
+          <a:ln w="28575">
+            <a:solidFill>
+              <a:srgbClr val="000066"/>
+            </a:solidFill>
+            <a:prstDash val="dash"/>
+          </a:ln>
+        </p:spPr>
+        <p:txBody>
+          <a:bodyPr anchor="ctr" wrap="square" lIns="91425" rIns="91425" tIns="45700" bIns="45700"/>
+          <a:lstStyle/>
+          <a:p>
+            <a:pPr algn="ctr">
+              <a:buNone/>
+            </a:pPr>
+            <a:r>
+              <a:rPr lang="pt-BR" sz="3600" b="0" i="0">
+                <a:solidFill>
+                  <a:srgbClr val="000066"/>
+                </a:solidFill>
+                <a:latin typeface="Arial"/>
+                <a:ea typeface="Arial"/>
+                <a:cs typeface="Arial"/>
+              </a:rPr>
+              <a:t>INSIRA A FOTO 3</a:t>
+            </a:r>
+          </a:p>
+        </p:txBody>
+      </p:sp>
+      <p:sp>
+        <p:nvSpPr>
+          <p:cNvPr id="103" name="Legenda 1"/>
+          <p:cNvSpPr txBox="1"/>
+          <p:nvPr/>
+        </p:nvSpPr>
+        <p:spPr>
+          <a:xfrm>
+            <a:off x="720000" y="32220000"/>
+            <a:ext cx="9540000" cy="864000"/>
+          </a:xfrm>
+          <a:prstGeom prst="rect">
+            <a:avLst/>
+          </a:prstGeom>
+          <a:noFill/>
+        </p:spPr>
+        <p:txBody>
+          <a:bodyPr anchor="t" wrap="square" lIns="91425" rIns="91425" tIns="45700" bIns="45700"/>
+          <a:lstStyle/>
+          <a:p>
+            <a:pPr algn="ctr">
+              <a:buNone/>
+            </a:pPr>
+            <a:r>
+              <a:rPr lang="pt-BR" sz="2400" b="0" i="0">
+                <a:solidFill>
+                  <a:srgbClr val="000066"/>
+                </a:solidFill>
+                <a:latin typeface="Arial"/>
+                <a:ea typeface="Arial"/>
+                <a:cs typeface="Arial"/>
+              </a:rPr>
+              <a:t>Fig. 1 - Condicionamento da paciente antes do atendimento</a:t>
+            </a:r>
+          </a:p>
+        </p:txBody>
+      </p:sp>
+      <p:sp>
+        <p:nvSpPr>
+          <p:cNvPr id="104" name="Legenda 2"/>
+          <p:cNvSpPr txBox="1"/>
+          <p:nvPr/>
+        </p:nvSpPr>
+        <p:spPr>
+          <a:xfrm>
+            <a:off x="11430000" y="32220000"/>
+            <a:ext cx="9540000" cy="864000"/>
+          </a:xfrm>
+          <a:prstGeom prst="rect">
+            <a:avLst/>
+          </a:prstGeom>
+          <a:noFill/>
+        </p:spPr>
+        <p:txBody>
+          <a:bodyPr anchor="t" wrap="square" lIns="91425" rIns="91425" tIns="45700" bIns="45700"/>
+          <a:lstStyle/>
+          <a:p>
+            <a:pPr algn="ctr">
+              <a:buNone/>
+            </a:pPr>
+            <a:r>
+              <a:rPr lang="pt-BR" sz="2400" b="0" i="0">
+                <a:solidFill>
+                  <a:srgbClr val="000066"/>
+                </a:solidFill>
+                <a:latin typeface="Arial"/>
+                <a:ea typeface="Arial"/>
+                <a:cs typeface="Arial"/>
+              </a:rPr>
+              <a:t>Fig. 2 - Pedagogia visual durante a consulta</a:t>
+            </a:r>
+          </a:p>
+        </p:txBody>
+      </p:sp>
+      <p:sp>
+        <p:nvSpPr>
+          <p:cNvPr id="105" name="Legenda 3"/>
+          <p:cNvSpPr txBox="1"/>
+          <p:nvPr/>
+        </p:nvSpPr>
+        <p:spPr>
+          <a:xfrm>
+            <a:off x="22140000" y="32220000"/>
+            <a:ext cx="9540000" cy="864000"/>
+          </a:xfrm>
+          <a:prstGeom prst="rect">
+            <a:avLst/>
+          </a:prstGeom>
+          <a:noFill/>
+        </p:spPr>
+        <p:txBody>
+          <a:bodyPr anchor="t" wrap="square" lIns="91425" rIns="91425" tIns="45700" bIns="45700"/>
+          <a:lstStyle/>
+          <a:p>
+            <a:pPr algn="ctr">
+              <a:buNone/>
+            </a:pPr>
+            <a:r>
+              <a:rPr lang="pt-BR" sz="2400" b="0" i="0">
+                <a:solidFill>
+                  <a:srgbClr val="000066"/>
+                </a:solidFill>
+                <a:latin typeface="Arial"/>
+                <a:ea typeface="Arial"/>
+                <a:cs typeface="Arial"/>
+              </a:rPr>
+              <a:t>Fig. 3 - Adequação do meio bucal</a:t>
+            </a:r>
+          </a:p>
+        </p:txBody>
+      </p:sp>
     </p:spTree>
   </p:cSld>
   <p:clrMapOvr>

</xml_diff>